<commit_message>
Update the architecture diagram, and keep only the presentation in docs/
- specs/site-generator/architecture.png: redrawn for the current state and
  the palette of the project slides. It showed the Slice A architecture with
  EPAM DIAL as a dashed "planned" box; now it shows the agents writing the
  deck, DIAL as VPN-only, the mock interview on a local server, and hosting
  it all on AWS as the dashed, not-built part. Alt text updated to match
- docs/: the September one-pager only. The original single-page prototype
  and the blank slide template were reference material, not documentation;
  both stay in git history

Co-Authored-By: Claude Opus 5 <noreply@anthropic.com>
</commit_message>
<xml_diff>
--- a/docs/Lukasz_Kwasniewski - AI_Upskill - September.2026.pptx
+++ b/docs/Lukasz_Kwasniewski - AI_Upskill - September.2026.pptx
@@ -815,7 +815,7 @@
     <p:bg>
       <p:bgPr>
         <a:solidFill>
-          <a:srgbClr val="06101F"/>
+          <a:srgbClr val="F6F5F0"/>
         </a:solidFill>
         <a:effectLst/>
       </p:bgPr>
@@ -851,7 +851,7 @@
           <a:noFill/>
           <a:ln w="3810">
             <a:solidFill>
-              <a:srgbClr val="0D1E33"/>
+              <a:srgbClr val="E9E7E0"/>
             </a:solidFill>
             <a:prstDash val="solid"/>
           </a:ln>
@@ -881,7 +881,7 @@
           <a:noFill/>
           <a:ln w="3810">
             <a:solidFill>
-              <a:srgbClr val="0D1E33"/>
+              <a:srgbClr val="E9E7E0"/>
             </a:solidFill>
             <a:prstDash val="solid"/>
           </a:ln>
@@ -911,7 +911,7 @@
           <a:noFill/>
           <a:ln w="3810">
             <a:solidFill>
-              <a:srgbClr val="0D1E33"/>
+              <a:srgbClr val="E9E7E0"/>
             </a:solidFill>
             <a:prstDash val="solid"/>
           </a:ln>
@@ -941,7 +941,7 @@
           <a:noFill/>
           <a:ln w="3810">
             <a:solidFill>
-              <a:srgbClr val="0D1E33"/>
+              <a:srgbClr val="E9E7E0"/>
             </a:solidFill>
             <a:prstDash val="solid"/>
           </a:ln>
@@ -971,7 +971,7 @@
           <a:noFill/>
           <a:ln w="3810">
             <a:solidFill>
-              <a:srgbClr val="0D1E33"/>
+              <a:srgbClr val="E9E7E0"/>
             </a:solidFill>
             <a:prstDash val="solid"/>
           </a:ln>
@@ -1001,7 +1001,7 @@
           <a:noFill/>
           <a:ln w="3810">
             <a:solidFill>
-              <a:srgbClr val="0D1E33"/>
+              <a:srgbClr val="E9E7E0"/>
             </a:solidFill>
             <a:prstDash val="solid"/>
           </a:ln>
@@ -1031,7 +1031,7 @@
           <a:noFill/>
           <a:ln w="3810">
             <a:solidFill>
-              <a:srgbClr val="0D1E33"/>
+              <a:srgbClr val="E9E7E0"/>
             </a:solidFill>
             <a:prstDash val="solid"/>
           </a:ln>
@@ -1061,7 +1061,7 @@
           <a:noFill/>
           <a:ln w="3810">
             <a:solidFill>
-              <a:srgbClr val="0D1E33"/>
+              <a:srgbClr val="E9E7E0"/>
             </a:solidFill>
             <a:prstDash val="solid"/>
           </a:ln>
@@ -1091,7 +1091,7 @@
           <a:noFill/>
           <a:ln w="3810">
             <a:solidFill>
-              <a:srgbClr val="0D1E33"/>
+              <a:srgbClr val="E9E7E0"/>
             </a:solidFill>
             <a:prstDash val="solid"/>
           </a:ln>
@@ -1121,7 +1121,7 @@
           <a:noFill/>
           <a:ln w="3810">
             <a:solidFill>
-              <a:srgbClr val="0D1E33"/>
+              <a:srgbClr val="E9E7E0"/>
             </a:solidFill>
             <a:prstDash val="solid"/>
           </a:ln>
@@ -1151,7 +1151,7 @@
           <a:noFill/>
           <a:ln w="3810">
             <a:solidFill>
-              <a:srgbClr val="0D1E33"/>
+              <a:srgbClr val="E9E7E0"/>
             </a:solidFill>
             <a:prstDash val="solid"/>
           </a:ln>
@@ -1181,7 +1181,7 @@
           <a:noFill/>
           <a:ln w="3810">
             <a:solidFill>
-              <a:srgbClr val="0D1E33"/>
+              <a:srgbClr val="E9E7E0"/>
             </a:solidFill>
             <a:prstDash val="solid"/>
           </a:ln>
@@ -1211,7 +1211,7 @@
           <a:noFill/>
           <a:ln w="3810">
             <a:solidFill>
-              <a:srgbClr val="0D1E33"/>
+              <a:srgbClr val="E9E7E0"/>
             </a:solidFill>
             <a:prstDash val="solid"/>
           </a:ln>
@@ -1241,7 +1241,7 @@
           <a:noFill/>
           <a:ln w="3810">
             <a:solidFill>
-              <a:srgbClr val="0D1E33"/>
+              <a:srgbClr val="E9E7E0"/>
             </a:solidFill>
             <a:prstDash val="solid"/>
           </a:ln>
@@ -1271,7 +1271,7 @@
           <a:noFill/>
           <a:ln w="3810">
             <a:solidFill>
-              <a:srgbClr val="0D1E33"/>
+              <a:srgbClr val="E9E7E0"/>
             </a:solidFill>
             <a:prstDash val="solid"/>
           </a:ln>
@@ -1301,7 +1301,7 @@
           <a:noFill/>
           <a:ln w="3810">
             <a:solidFill>
-              <a:srgbClr val="0D1E33"/>
+              <a:srgbClr val="E9E7E0"/>
             </a:solidFill>
             <a:prstDash val="solid"/>
           </a:ln>
@@ -1331,7 +1331,7 @@
           <a:noFill/>
           <a:ln w="3810">
             <a:solidFill>
-              <a:srgbClr val="0D1E33"/>
+              <a:srgbClr val="E9E7E0"/>
             </a:solidFill>
             <a:prstDash val="solid"/>
           </a:ln>
@@ -1361,7 +1361,7 @@
           <a:noFill/>
           <a:ln w="3810">
             <a:solidFill>
-              <a:srgbClr val="0D1E33"/>
+              <a:srgbClr val="E9E7E0"/>
             </a:solidFill>
             <a:prstDash val="solid"/>
           </a:ln>
@@ -1391,7 +1391,7 @@
           <a:noFill/>
           <a:ln w="3810">
             <a:solidFill>
-              <a:srgbClr val="0D1E33"/>
+              <a:srgbClr val="E9E7E0"/>
             </a:solidFill>
             <a:prstDash val="solid"/>
           </a:ln>
@@ -1421,7 +1421,7 @@
           <a:noFill/>
           <a:ln w="3810">
             <a:solidFill>
-              <a:srgbClr val="0D1E33"/>
+              <a:srgbClr val="E9E7E0"/>
             </a:solidFill>
             <a:prstDash val="solid"/>
           </a:ln>
@@ -1451,7 +1451,7 @@
           <a:noFill/>
           <a:ln w="3810">
             <a:solidFill>
-              <a:srgbClr val="0D1E33"/>
+              <a:srgbClr val="E9E7E0"/>
             </a:solidFill>
             <a:prstDash val="solid"/>
           </a:ln>
@@ -1481,7 +1481,7 @@
           <a:noFill/>
           <a:ln w="3810">
             <a:solidFill>
-              <a:srgbClr val="0D1E33"/>
+              <a:srgbClr val="E9E7E0"/>
             </a:solidFill>
             <a:prstDash val="solid"/>
           </a:ln>
@@ -1509,11 +1509,11 @@
             <a:avLst/>
           </a:prstGeom>
           <a:solidFill>
-            <a:srgbClr val="00C8E0"/>
+            <a:srgbClr val="3F45C4"/>
           </a:solidFill>
           <a:ln w="12700">
             <a:solidFill>
-              <a:srgbClr val="00C8E0"/>
+              <a:srgbClr val="3F45C4"/>
             </a:solidFill>
             <a:prstDash val="solid"/>
           </a:ln>
@@ -1541,11 +1541,11 @@
             <a:avLst/>
           </a:prstGeom>
           <a:solidFill>
-            <a:srgbClr val="0A1525"/>
+            <a:srgbClr val="1B2233"/>
           </a:solidFill>
           <a:ln w="6350">
             <a:solidFill>
-              <a:srgbClr val="132238"/>
+              <a:srgbClr val="1B2233"/>
             </a:solidFill>
             <a:prstDash val="solid"/>
           </a:ln>
@@ -1573,11 +1573,11 @@
             <a:avLst/>
           </a:prstGeom>
           <a:solidFill>
-            <a:srgbClr val="06101F"/>
+            <a:srgbClr val="2A3450"/>
           </a:solidFill>
           <a:ln w="7620">
             <a:solidFill>
-              <a:srgbClr val="4A6380"/>
+              <a:srgbClr val="5E6780"/>
             </a:solidFill>
             <a:prstDash val="solid"/>
           </a:ln>
@@ -1617,10 +1617,10 @@
             <a:r>
               <a:rPr lang="en-US" sz="750" kern="0" spc="200" dirty="0">
                 <a:solidFill>
-                  <a:srgbClr val="4A6380"/>
-                </a:solidFill>
-              </a:rPr>
-              <a:t>AI UPSKILL · MAY 2026</a:t>
+                  <a:srgbClr val="AEB4F5"/>
+                </a:solidFill>
+              </a:rPr>
+              <a:t>AI UPSKILL · SEPT 2026</a:t>
             </a:r>
             <a:endParaRPr lang="en-US" sz="750" dirty="0"/>
           </a:p>
@@ -1653,13 +1653,13 @@
             <a:r>
               <a:rPr lang="en-US" sz="2200" b="1" dirty="0">
                 <a:solidFill>
-                  <a:srgbClr val="FFFFFF"/>
+                  <a:srgbClr val="F6F5F0"/>
                 </a:solidFill>
                 <a:latin typeface="Calibri" pitchFamily="34" charset="0"/>
                 <a:ea typeface="Calibri" pitchFamily="34" charset="-122"/>
                 <a:cs typeface="Calibri" pitchFamily="34" charset="-120"/>
               </a:rPr>
-              <a:t>INTERACTIVE LEARNING SITE GENERATOR</a:t>
+              <a:t>LEARNING SITE, QUIZ AND MOCK INTERVIEW</a:t>
             </a:r>
             <a:endParaRPr lang="en-US" sz="2200" dirty="0"/>
           </a:p>
@@ -1680,11 +1680,11 @@
             <a:avLst/>
           </a:prstGeom>
           <a:solidFill>
-            <a:srgbClr val="06101F"/>
+            <a:srgbClr val="2A3450"/>
           </a:solidFill>
           <a:ln w="10160">
             <a:solidFill>
-              <a:srgbClr val="132238"/>
+              <a:srgbClr val="1B2233"/>
             </a:solidFill>
             <a:prstDash val="solid"/>
           </a:ln>
@@ -1724,7 +1724,7 @@
             <a:r>
               <a:rPr lang="en-US" sz="800" kern="0" spc="150" dirty="0">
                 <a:solidFill>
-                  <a:srgbClr val="4A6380"/>
+                  <a:srgbClr val="AEB4F5"/>
                 </a:solidFill>
               </a:rPr>
               <a:t>3-WEEK INITIATIVE</a:t>
@@ -1748,11 +1748,11 @@
             <a:avLst/>
           </a:prstGeom>
           <a:solidFill>
-            <a:srgbClr val="0C1B30"/>
+            <a:srgbClr val="FDFCF9"/>
           </a:solidFill>
           <a:ln w="8890">
             <a:solidFill>
-              <a:srgbClr val="132238"/>
+              <a:srgbClr val="DDDAD0"/>
             </a:solidFill>
             <a:prstDash val="solid"/>
           </a:ln>
@@ -1792,7 +1792,7 @@
             <a:r>
               <a:rPr lang="en-US" sz="750" b="1" kern="0" spc="250" dirty="0">
                 <a:solidFill>
-                  <a:srgbClr val="4A6380"/>
+                  <a:srgbClr val="3F45C4"/>
                 </a:solidFill>
               </a:rPr>
               <a:t>TEAM</a:t>
@@ -1818,7 +1818,7 @@
           <a:noFill/>
           <a:ln w="12700">
             <a:solidFill>
-              <a:srgbClr val="00C8E0"/>
+              <a:srgbClr val="3F45C4"/>
             </a:solidFill>
             <a:prstDash val="solid"/>
           </a:ln>
@@ -1858,7 +1858,7 @@
             <a:r>
               <a:rPr lang="pl-PL" sz="1100" b="1" dirty="0">
                 <a:solidFill>
-                  <a:srgbClr val="FFFFFF"/>
+                  <a:srgbClr val="1B2233"/>
                 </a:solidFill>
               </a:rPr>
               <a:t>Łukasz Kwaśniewski</a:t>
@@ -1872,7 +1872,7 @@
             <a:r>
               <a:rPr lang="pl-PL" sz="850" dirty="0">
                 <a:solidFill>
-                  <a:srgbClr val="00C8E0"/>
+                  <a:srgbClr val="3F45C4"/>
                 </a:solidFill>
               </a:rPr>
               <a:t>Student</a:t>
@@ -1896,11 +1896,11 @@
             <a:avLst/>
           </a:prstGeom>
           <a:solidFill>
-            <a:srgbClr val="0C1B30"/>
+            <a:srgbClr val="FDFCF9"/>
           </a:solidFill>
           <a:ln w="8890">
             <a:solidFill>
-              <a:srgbClr val="132238"/>
+              <a:srgbClr val="DDDAD0"/>
             </a:solidFill>
             <a:prstDash val="solid"/>
           </a:ln>
@@ -1940,7 +1940,7 @@
             <a:r>
               <a:rPr lang="en-US" sz="750" b="1" kern="0" spc="250" dirty="0">
                 <a:solidFill>
-                  <a:srgbClr val="4A6380"/>
+                  <a:srgbClr val="3F45C4"/>
                 </a:solidFill>
               </a:rPr>
               <a:t>TECH STACK</a:t>
@@ -1966,7 +1966,7 @@
           <a:noFill/>
           <a:ln w="12700">
             <a:solidFill>
-              <a:srgbClr val="00C8E0"/>
+              <a:srgbClr val="3F45C4"/>
             </a:solidFill>
             <a:prstDash val="solid"/>
           </a:ln>
@@ -1994,11 +1994,11 @@
             <a:avLst/>
           </a:prstGeom>
           <a:solidFill>
-            <a:srgbClr val="06101F"/>
+            <a:srgbClr val="ECEEFA"/>
           </a:solidFill>
           <a:ln w="8890">
             <a:solidFill>
-              <a:srgbClr val="132238"/>
+              <a:srgbClr val="D5D8F2"/>
             </a:solidFill>
             <a:prstDash val="solid"/>
           </a:ln>
@@ -2038,7 +2038,7 @@
             <a:r>
               <a:rPr lang="en-US" sz="750" dirty="0">
                 <a:solidFill>
-                  <a:srgbClr val="A8BFDA"/>
+                  <a:srgbClr val="2E3399"/>
                 </a:solidFill>
               </a:rPr>
               <a:t>Node.js</a:t>
@@ -2062,11 +2062,11 @@
             <a:avLst/>
           </a:prstGeom>
           <a:solidFill>
-            <a:srgbClr val="06101F"/>
+            <a:srgbClr val="ECEEFA"/>
           </a:solidFill>
           <a:ln w="8890">
             <a:solidFill>
-              <a:srgbClr val="132238"/>
+              <a:srgbClr val="D5D8F2"/>
             </a:solidFill>
             <a:prstDash val="solid"/>
           </a:ln>
@@ -2106,7 +2106,7 @@
             <a:r>
               <a:rPr lang="en-US" sz="750" dirty="0">
                 <a:solidFill>
-                  <a:srgbClr val="A8BFDA"/>
+                  <a:srgbClr val="2E3399"/>
                 </a:solidFill>
               </a:rPr>
               <a:t>Cloudflare</a:t>
@@ -2130,11 +2130,11 @@
             <a:avLst/>
           </a:prstGeom>
           <a:solidFill>
-            <a:srgbClr val="06101F"/>
+            <a:srgbClr val="ECEEFA"/>
           </a:solidFill>
           <a:ln w="8890">
             <a:solidFill>
-              <a:srgbClr val="132238"/>
+              <a:srgbClr val="D5D8F2"/>
             </a:solidFill>
             <a:prstDash val="solid"/>
           </a:ln>
@@ -2174,7 +2174,7 @@
             <a:r>
               <a:rPr lang="en-US" sz="750" dirty="0">
                 <a:solidFill>
-                  <a:srgbClr val="A8BFDA"/>
+                  <a:srgbClr val="2E3399"/>
                 </a:solidFill>
               </a:rPr>
               <a:t>GitHub</a:t>
@@ -2198,11 +2198,11 @@
             <a:avLst/>
           </a:prstGeom>
           <a:solidFill>
-            <a:srgbClr val="06101F"/>
+            <a:srgbClr val="ECEEFA"/>
           </a:solidFill>
           <a:ln w="8890">
             <a:solidFill>
-              <a:srgbClr val="132238"/>
+              <a:srgbClr val="D5D8F2"/>
             </a:solidFill>
             <a:prstDash val="solid"/>
           </a:ln>
@@ -2242,7 +2242,7 @@
             <a:r>
               <a:rPr lang="en-US" sz="750" dirty="0">
                 <a:solidFill>
-                  <a:srgbClr val="A8BFDA"/>
+                  <a:srgbClr val="2E3399"/>
                 </a:solidFill>
               </a:rPr>
               <a:t>Claude Code</a:t>
@@ -2266,11 +2266,11 @@
             <a:avLst/>
           </a:prstGeom>
           <a:solidFill>
-            <a:srgbClr val="06101F"/>
+            <a:srgbClr val="ECEEFA"/>
           </a:solidFill>
           <a:ln w="8890">
             <a:solidFill>
-              <a:srgbClr val="132238"/>
+              <a:srgbClr val="D5D8F2"/>
             </a:solidFill>
             <a:prstDash val="solid"/>
           </a:ln>
@@ -2310,7 +2310,7 @@
             <a:r>
               <a:rPr lang="en-US" sz="750" dirty="0">
                 <a:solidFill>
-                  <a:srgbClr val="A8BFDA"/>
+                  <a:srgbClr val="2E3399"/>
                 </a:solidFill>
               </a:rPr>
               <a:t>js-yaml</a:t>
@@ -2334,11 +2334,11 @@
             <a:avLst/>
           </a:prstGeom>
           <a:solidFill>
-            <a:srgbClr val="06101F"/>
+            <a:srgbClr val="ECEEFA"/>
           </a:solidFill>
           <a:ln w="8890">
             <a:solidFill>
-              <a:srgbClr val="132238"/>
+              <a:srgbClr val="D5D8F2"/>
             </a:solidFill>
             <a:prstDash val="solid"/>
           </a:ln>
@@ -2378,7 +2378,7 @@
             <a:r>
               <a:rPr lang="en-US" sz="750" dirty="0">
                 <a:solidFill>
-                  <a:srgbClr val="A8BFDA"/>
+                  <a:srgbClr val="2E3399"/>
                 </a:solidFill>
               </a:rPr>
               <a:t>cheerio</a:t>
@@ -2402,11 +2402,11 @@
             <a:avLst/>
           </a:prstGeom>
           <a:solidFill>
-            <a:srgbClr val="06101F"/>
+            <a:srgbClr val="ECEEFA"/>
           </a:solidFill>
           <a:ln w="8890">
             <a:solidFill>
-              <a:srgbClr val="132238"/>
+              <a:srgbClr val="D5D8F2"/>
             </a:solidFill>
             <a:prstDash val="solid"/>
           </a:ln>
@@ -2446,7 +2446,7 @@
             <a:r>
               <a:rPr lang="en-US" sz="750" dirty="0">
                 <a:solidFill>
-                  <a:srgbClr val="A8BFDA"/>
+                  <a:srgbClr val="2E3399"/>
                 </a:solidFill>
               </a:rPr>
               <a:t>EPAM DIAL</a:t>
@@ -2470,11 +2470,11 @@
             <a:avLst/>
           </a:prstGeom>
           <a:solidFill>
-            <a:srgbClr val="0C1B30"/>
+            <a:srgbClr val="FDFCF9"/>
           </a:solidFill>
           <a:ln w="8890">
             <a:solidFill>
-              <a:srgbClr val="132238"/>
+              <a:srgbClr val="DDDAD0"/>
             </a:solidFill>
             <a:prstDash val="solid"/>
           </a:ln>
@@ -2514,7 +2514,7 @@
             <a:r>
               <a:rPr lang="en-US" sz="750" b="1" kern="0" spc="250" dirty="0">
                 <a:solidFill>
-                  <a:srgbClr val="4A6380"/>
+                  <a:srgbClr val="3F45C4"/>
                 </a:solidFill>
               </a:rPr>
               <a:t>BUSINESS CHALLENGES</a:t>
@@ -2540,7 +2540,7 @@
           <a:noFill/>
           <a:ln w="12700">
             <a:solidFill>
-              <a:srgbClr val="00C8E0"/>
+              <a:srgbClr val="3F45C4"/>
             </a:solidFill>
             <a:prstDash val="solid"/>
           </a:ln>
@@ -2584,7 +2584,7 @@
             <a:r>
               <a:rPr lang="en-US" sz="850" dirty="0">
                 <a:solidFill>
-                  <a:srgbClr val="A8BFDA"/>
+                  <a:srgbClr val="4A5263"/>
                 </a:solidFill>
               </a:rPr>
               <a:t>Study content trapped in one-off files</a:t>
@@ -2602,10 +2602,10 @@
             <a:r>
               <a:rPr lang="en-US" sz="850" dirty="0">
                 <a:solidFill>
-                  <a:srgbClr val="A8BFDA"/>
-                </a:solidFill>
-              </a:rPr>
-              <a:t>New topics mean repetitive manual web work</a:t>
+                  <a:srgbClr val="4A5263"/>
+                </a:solidFill>
+              </a:rPr>
+              <a:t>New topics mean repetitive manual work</a:t>
             </a:r>
             <a:endParaRPr lang="en-US" sz="850" dirty="0"/>
           </a:p>
@@ -2620,10 +2620,10 @@
             <a:r>
               <a:rPr lang="en-US" sz="850" dirty="0">
                 <a:solidFill>
-                  <a:srgbClr val="A8BFDA"/>
-                </a:solidFill>
-              </a:rPr>
-              <a:t>“Spec-driven” claimed more than proven</a:t>
+                  <a:srgbClr val="4A5263"/>
+                </a:solidFill>
+              </a:rPr>
+              <a:t>Reading is not practice: no self-check</a:t>
             </a:r>
             <a:endParaRPr lang="en-US" sz="850" dirty="0"/>
           </a:p>
@@ -2638,10 +2638,10 @@
             <a:r>
               <a:rPr lang="en-US" sz="850" dirty="0">
                 <a:solidFill>
-                  <a:srgbClr val="A8BFDA"/>
-                </a:solidFill>
-              </a:rPr>
-              <a:t>No path yet from bare questions to an LLM</a:t>
+                  <a:srgbClr val="4A5263"/>
+                </a:solidFill>
+              </a:rPr>
+              <a:t>Generated answers need a review step</a:t>
             </a:r>
             <a:endParaRPr lang="en-US" sz="850" dirty="0"/>
           </a:p>
@@ -2662,11 +2662,11 @@
             <a:avLst/>
           </a:prstGeom>
           <a:solidFill>
-            <a:srgbClr val="0C1B30"/>
+            <a:srgbClr val="FDFCF9"/>
           </a:solidFill>
           <a:ln w="8890">
             <a:solidFill>
-              <a:srgbClr val="132238"/>
+              <a:srgbClr val="DDDAD0"/>
             </a:solidFill>
             <a:prstDash val="solid"/>
           </a:ln>
@@ -2706,7 +2706,7 @@
             <a:r>
               <a:rPr lang="en-US" sz="750" b="1" kern="0" spc="250" dirty="0">
                 <a:solidFill>
-                  <a:srgbClr val="4A6380"/>
+                  <a:srgbClr val="3F45C4"/>
                 </a:solidFill>
               </a:rPr>
               <a:t>INTRODUCTION</a:t>
@@ -2732,7 +2732,7 @@
           <a:noFill/>
           <a:ln w="12700">
             <a:solidFill>
-              <a:srgbClr val="00C8E0"/>
+              <a:srgbClr val="3F45C4"/>
             </a:solidFill>
             <a:prstDash val="solid"/>
           </a:ln>
@@ -2772,10 +2772,10 @@
             <a:r>
               <a:rPr lang="en-US" sz="900" dirty="0">
                 <a:solidFill>
-                  <a:srgbClr val="A8BFDA"/>
-                </a:solidFill>
-              </a:rPr>
-              <a:t>A static-site generator for the AI Upskill initiative: structured Q&amp;A decks become a fast, interactive, self-quizzing site. The first deck — 44 AI-engineering interview questions — proves the pipeline end to end.</a:t>
+                  <a:srgbClr val="4A5263"/>
+                </a:solidFill>
+              </a:rPr>
+              <a:t>A static-site generator plus three agent features: one topic title becomes a structured Q&amp;A deck, a quiz on every card, and a mock interview that grades spoken-style answers against those cards.</a:t>
             </a:r>
             <a:endParaRPr lang="en-US" sz="900" dirty="0"/>
           </a:p>
@@ -2796,11 +2796,11 @@
             <a:avLst/>
           </a:prstGeom>
           <a:solidFill>
-            <a:srgbClr val="0C1B30"/>
+            <a:srgbClr val="FDFCF9"/>
           </a:solidFill>
           <a:ln w="8890">
             <a:solidFill>
-              <a:srgbClr val="132238"/>
+              <a:srgbClr val="DDDAD0"/>
             </a:solidFill>
             <a:prstDash val="solid"/>
           </a:ln>
@@ -2840,7 +2840,7 @@
             <a:r>
               <a:rPr lang="en-US" sz="750" b="1" kern="0" spc="250" dirty="0">
                 <a:solidFill>
-                  <a:srgbClr val="4A6380"/>
+                  <a:srgbClr val="3F45C4"/>
                 </a:solidFill>
               </a:rPr>
               <a:t>SOLUTION</a:t>
@@ -2866,7 +2866,7 @@
           <a:noFill/>
           <a:ln w="12700">
             <a:solidFill>
-              <a:srgbClr val="00C8E0"/>
+              <a:srgbClr val="3F45C4"/>
             </a:solidFill>
             <a:prstDash val="solid"/>
           </a:ln>
@@ -2894,11 +2894,11 @@
             <a:avLst/>
           </a:prstGeom>
           <a:solidFill>
-            <a:srgbClr val="06101F"/>
+            <a:srgbClr val="FDFCF9"/>
           </a:solidFill>
           <a:ln w="8890">
             <a:solidFill>
-              <a:srgbClr val="132238"/>
+              <a:srgbClr val="DDDAD0"/>
             </a:solidFill>
             <a:prstDash val="solid"/>
           </a:ln>
@@ -2956,7 +2956,7 @@
           <a:noFill/>
           <a:ln w="5080">
             <a:solidFill>
-              <a:srgbClr val="132238"/>
+              <a:srgbClr val="DDDAD0"/>
             </a:solidFill>
             <a:prstDash val="solid"/>
           </a:ln>
@@ -2999,10 +2999,10 @@
             <a:r>
               <a:rPr lang="en-US" sz="900" dirty="0">
                 <a:solidFill>
-                  <a:srgbClr val="A8BFDA"/>
-                </a:solidFill>
-              </a:rPr>
-              <a:t>Node.js build script renders each deck’s YAML through a template lifted from the original prototype’s own CSS/JS — zero framework. A one-time script (cheerio) migrated the first deck from HTML, self-validating question counts against the source. Output is fully static, deployed on Cloudflare Pages. Content fields trust a small set of inline HTML, a deliberate choice since decks are author-written.</a:t>
+                  <a:srgbClr val="4A5263"/>
+                </a:solidFill>
+              </a:rPr>
+              <a:t>Node.js build renders each deck's YAML through a template lifted from the prototype's own CSS/JS, zero framework. Three agent slices run on EPAM DIAL: quiz items generated ahead of time and committed as a diff, a mock interview served by a local server, and a pipeline that plans, writes and reviews a whole deck from one title, stopping twice for human review. Each agent uses the cheapest model that passed a spot check.</a:t>
             </a:r>
             <a:endParaRPr lang="en-US" sz="900" dirty="0"/>
           </a:p>
@@ -3023,11 +3023,11 @@
             <a:avLst/>
           </a:prstGeom>
           <a:solidFill>
-            <a:srgbClr val="0C1B30"/>
+            <a:srgbClr val="FDFCF9"/>
           </a:solidFill>
           <a:ln w="8890">
             <a:solidFill>
-              <a:srgbClr val="132238"/>
+              <a:srgbClr val="DDDAD0"/>
             </a:solidFill>
             <a:prstDash val="solid"/>
           </a:ln>
@@ -3067,7 +3067,7 @@
             <a:r>
               <a:rPr lang="en-US" sz="750" b="1" kern="0" spc="250" dirty="0">
                 <a:solidFill>
-                  <a:srgbClr val="4A6380"/>
+                  <a:srgbClr val="3F45C4"/>
                 </a:solidFill>
               </a:rPr>
               <a:t>OTHERS</a:t>
@@ -3093,7 +3093,7 @@
           <a:noFill/>
           <a:ln w="12700">
             <a:solidFill>
-              <a:srgbClr val="00C8E0"/>
+              <a:srgbClr val="3F45C4"/>
             </a:solidFill>
             <a:prstDash val="solid"/>
           </a:ln>
@@ -3121,11 +3121,11 @@
             <a:avLst/>
           </a:prstGeom>
           <a:solidFill>
-            <a:srgbClr val="6B28E0"/>
+            <a:srgbClr val="D08A2E"/>
           </a:solidFill>
           <a:ln w="12700">
             <a:solidFill>
-              <a:srgbClr val="6B28E0"/>
+              <a:srgbClr val="D08A2E"/>
             </a:solidFill>
             <a:prstDash val="solid"/>
           </a:ln>
@@ -3165,7 +3165,7 @@
             <a:r>
               <a:rPr lang="en-US" sz="750" b="1" kern="0" spc="200" dirty="0">
                 <a:solidFill>
-                  <a:srgbClr val="4A6380"/>
+                  <a:srgbClr val="3F45C4"/>
                 </a:solidFill>
               </a:rPr>
               <a:t>IMPACT</a:t>
@@ -3204,10 +3204,10 @@
             <a:r>
               <a:rPr lang="en-US" sz="850" dirty="0">
                 <a:solidFill>
-                  <a:srgbClr val="A8BFDA"/>
-                </a:solidFill>
-              </a:rPr>
-              <a:t>Working PoC verified end-to-end in a real browser: search, filters, expand/collapse, confidence tracking and theme toggle all match the original exactly. A new topic is now one YAML file, not a new page.</a:t>
+                  <a:srgbClr val="4A5263"/>
+                </a:solidFill>
+              </a:rPr>
+              <a:t>Live behind Cloudflare Access: 44 interview questions, each with a generated quiz item. The mock interview grades answers against the cards and names what was missed. A new topic is one command, cents per deck.</a:t>
             </a:r>
             <a:endParaRPr lang="en-US" sz="850" dirty="0"/>
           </a:p>
@@ -3230,7 +3230,7 @@
           <a:noFill/>
           <a:ln w="5080">
             <a:solidFill>
-              <a:srgbClr val="132238"/>
+              <a:srgbClr val="DDDAD0"/>
             </a:solidFill>
             <a:prstDash val="solid"/>
           </a:ln>
@@ -3258,11 +3258,11 @@
             <a:avLst/>
           </a:prstGeom>
           <a:solidFill>
-            <a:srgbClr val="00C8E0"/>
+            <a:srgbClr val="3F45C4"/>
           </a:solidFill>
           <a:ln w="12700">
             <a:solidFill>
-              <a:srgbClr val="00C8E0"/>
+              <a:srgbClr val="3F45C4"/>
             </a:solidFill>
             <a:prstDash val="solid"/>
           </a:ln>
@@ -3302,7 +3302,7 @@
             <a:r>
               <a:rPr lang="en-US" sz="750" b="1" kern="0" spc="200" dirty="0">
                 <a:solidFill>
-                  <a:srgbClr val="4A6380"/>
+                  <a:srgbClr val="3F45C4"/>
                 </a:solidFill>
               </a:rPr>
               <a:t>LEARNINGS</a:t>
@@ -3341,10 +3341,10 @@
             <a:r>
               <a:rPr lang="en-US" sz="850" dirty="0">
                 <a:solidFill>
-                  <a:srgbClr val="A8BFDA"/>
-                </a:solidFill>
-              </a:rPr>
-              <a:t>Reading the actual script mattered: the confidence tracker was never persisted — an earlier assumption was wrong. EPAM DIAL exposes an Azure-OpenAI-shaped API, the concrete link to Azure AI Foundry.</a:t>
+                  <a:srgbClr val="4A5263"/>
+                </a:solidFill>
+              </a:rPr>
+              <a:t>DIAL is reachable only through the EPAM VPN, and whitelisting covers EPAM-managed cloud only, so the mock interview cannot be served from the public site. The personal key also rules out team use.</a:t>
             </a:r>
             <a:endParaRPr lang="en-US" sz="850" dirty="0"/>
           </a:p>
@@ -3367,7 +3367,7 @@
           <a:noFill/>
           <a:ln w="5080">
             <a:solidFill>
-              <a:srgbClr val="132238"/>
+              <a:srgbClr val="DDDAD0"/>
             </a:solidFill>
             <a:prstDash val="solid"/>
           </a:ln>
@@ -3395,11 +3395,11 @@
             <a:avLst/>
           </a:prstGeom>
           <a:solidFill>
-            <a:srgbClr val="00C8E0"/>
+            <a:srgbClr val="3F45C4"/>
           </a:solidFill>
           <a:ln w="12700">
             <a:solidFill>
-              <a:srgbClr val="00C8E0"/>
+              <a:srgbClr val="3F45C4"/>
             </a:solidFill>
             <a:prstDash val="solid"/>
           </a:ln>
@@ -3439,7 +3439,7 @@
             <a:r>
               <a:rPr lang="en-US" sz="750" b="1" kern="0" spc="200" dirty="0">
                 <a:solidFill>
-                  <a:srgbClr val="4A6380"/>
+                  <a:srgbClr val="3F45C4"/>
                 </a:solidFill>
               </a:rPr>
               <a:t>NEXT STEPS</a:t>
@@ -3478,10 +3478,10 @@
             <a:r>
               <a:rPr lang="en-US" sz="850" dirty="0">
                 <a:solidFill>
-                  <a:srgbClr val="A8BFDA"/>
-                </a:solidFill>
-              </a:rPr>
-              <a:t>Publish: public GitHub repo, Cloudflare Pages project, first live deploy. Wire answer generation to an EPAM DIAL endpoint for future bare-question decks. Package the publish flow as a reusable Claude Code skill.</a:t>
+                  <a:srgbClr val="4A5263"/>
+                </a:solidFill>
+              </a:rPr>
+              <a:t>Host the whole thing on AWS in an EPAM-managed account: whitelisted outbound IP, a non-personal key, and the interview served from the site instead of a laptop. Then a daily spend cap per person.</a:t>
             </a:r>
             <a:endParaRPr lang="en-US" sz="850" dirty="0"/>
           </a:p>
@@ -3504,7 +3504,7 @@
           <a:noFill/>
           <a:ln w="5080">
             <a:solidFill>
-              <a:srgbClr val="132238"/>
+              <a:srgbClr val="DDDAD0"/>
             </a:solidFill>
             <a:prstDash val="solid"/>
           </a:ln>
@@ -3544,7 +3544,7 @@
             <a:r>
               <a:rPr lang="en-US" sz="750" b="1" kern="0" spc="200" dirty="0">
                 <a:solidFill>
-                  <a:srgbClr val="4A6380"/>
+                  <a:srgbClr val="3F45C4"/>
                 </a:solidFill>
               </a:rPr>
               <a:t>ADDITIONAL NOTES</a:t>
@@ -3583,10 +3583,10 @@
             <a:r>
               <a:rPr lang="en-US" sz="850" dirty="0">
                 <a:solidFill>
-                  <a:srgbClr val="4A6380"/>
-                </a:solidFill>
-              </a:rPr>
-              <a:t>Spec: specs/site-generator/spec.md in-repo. Public repo + live URL added here once published — see the README’s status list for what’s left.</a:t>
+                  <a:srgbClr val="5E6475"/>
+                </a:solidFill>
+              </a:rPr>
+              <a:t>Specs in-repo: site-generator, agents, topic-pipeline. 47 tests. Repo: github.com/Lukasz-dataeng/ai-upskill-learning-site (site needs an allowed email).</a:t>
             </a:r>
             <a:endParaRPr lang="en-US" sz="850" dirty="0"/>
           </a:p>
@@ -3607,11 +3607,11 @@
             <a:avLst/>
           </a:prstGeom>
           <a:solidFill>
-            <a:srgbClr val="0A1525"/>
+            <a:srgbClr val="1B2233"/>
           </a:solidFill>
           <a:ln w="5080">
             <a:solidFill>
-              <a:srgbClr val="132238"/>
+              <a:srgbClr val="1B2233"/>
             </a:solidFill>
             <a:prstDash val="solid"/>
           </a:ln>
@@ -3651,10 +3651,10 @@
             <a:r>
               <a:rPr lang="en-US" sz="700" kern="0" spc="150" dirty="0">
                 <a:solidFill>
-                  <a:srgbClr val="4A6380"/>
-                </a:solidFill>
-              </a:rPr>
-              <a:t>.NET AI UPSKILL INITIATIVE — MAY 2026</a:t>
+                  <a:srgbClr val="C9CEDA"/>
+                </a:solidFill>
+              </a:rPr>
+              <a:t>.NET AI UPSKILL INITIATIVE · SEPTEMBER 2026</a:t>
             </a:r>
             <a:endParaRPr lang="en-US" sz="700" dirty="0"/>
           </a:p>
@@ -3687,7 +3687,7 @@
             <a:r>
               <a:rPr lang="en-US" sz="700" kern="0" spc="150" dirty="0">
                 <a:solidFill>
-                  <a:srgbClr val="4A6380"/>
+                  <a:srgbClr val="C9CEDA"/>
                 </a:solidFill>
               </a:rPr>
               <a:t>CONFIDENTIAL</a:t>

</xml_diff>